<commit_message>
integrate PrefWeb workspace and real presentation generation
</commit_message>
<xml_diff>
--- a/experiments/pptx_template/input/template.pptx
+++ b/experiments/pptx_template/input/template.pptx
@@ -184,7 +184,7 @@
           <a:p>
             <a:fld id="{1D8BD707-D9CF-40AE-B4C6-C98DA3205C09}" type="datetimeFigureOut">
               <a:rPr lang="en-US"/>
-              <a:t>8/12/26</a:t>
+              <a:t>8/13/26</a:t>
             </a:fld>
             <a:endParaRPr lang="en-US"/>
           </a:p>
@@ -355,7 +355,7 @@
           <a:p>
             <a:fld id="{1D8BD707-D9CF-40AE-B4C6-C98DA3205C09}" type="datetimeFigureOut">
               <a:rPr lang="en-US"/>
-              <a:t>8/12/26</a:t>
+              <a:t>8/13/26</a:t>
             </a:fld>
             <a:endParaRPr lang="en-US"/>
           </a:p>
@@ -569,7 +569,7 @@
           <a:p>
             <a:fld id="{1D8BD707-D9CF-40AE-B4C6-C98DA3205C09}" type="datetimeFigureOut">
               <a:rPr lang="en-US"/>
-              <a:t>8/12/26</a:t>
+              <a:t>8/13/26</a:t>
             </a:fld>
             <a:endParaRPr lang="en-US"/>
           </a:p>
@@ -717,7 +717,7 @@
           <a:p>
             <a:fld id="{1D8BD707-D9CF-40AE-B4C6-C98DA3205C09}" type="datetimeFigureOut">
               <a:rPr lang="en-US"/>
-              <a:t>8/12/26</a:t>
+              <a:t>8/13/26</a:t>
             </a:fld>
             <a:endParaRPr lang="en-US"/>
           </a:p>
@@ -836,7 +836,7 @@
           <a:p>
             <a:fld id="{1D8BD707-D9CF-40AE-B4C6-C98DA3205C09}" type="datetimeFigureOut">
               <a:rPr lang="en-US"/>
-              <a:t>8/12/26</a:t>
+              <a:t>8/13/26</a:t>
             </a:fld>
             <a:endParaRPr lang="en-US"/>
           </a:p>
@@ -1055,7 +1055,7 @@
           <a:p>
             <a:fld id="{1D8BD707-D9CF-40AE-B4C6-C98DA3205C09}" type="datetimeFigureOut">
               <a:rPr lang="en-US"/>
-              <a:t>8/12/26</a:t>
+              <a:t>8/13/26</a:t>
             </a:fld>
             <a:endParaRPr lang="en-US"/>
           </a:p>
@@ -2029,7 +2029,7 @@
         <p:spPr>
           <a:xfrm>
             <a:off x="2601019" y="4360798"/>
-            <a:ext cx="2103755" cy="252729"/>
+            <a:ext cx="4838981" cy="252729"/>
           </a:xfrm>
           <a:prstGeom prst="rect">
             <a:avLst/>
@@ -2037,7 +2037,7 @@
         </p:spPr>
         <p:txBody>
           <a:bodyPr vert="horz" wrap="square" lIns="0" tIns="17145" rIns="0" bIns="0" rtlCol="0">
-            <a:spAutoFit/>
+            <a:noAutofit/>
           </a:bodyPr>
           <a:lstStyle/>
           <a:p>
@@ -3405,7 +3405,7 @@
         <p:spPr>
           <a:xfrm>
             <a:off x="5835053" y="4225620"/>
-            <a:ext cx="2002155" cy="615950"/>
+            <a:ext cx="2002155" cy="309700"/>
           </a:xfrm>
           <a:prstGeom prst="rect">
             <a:avLst/>
@@ -3426,82 +3426,18 @@
               </a:spcBef>
             </a:pPr>
             <a:r>
-              <a:rPr sz="1450" b="1" spc="-10" dirty="0">
+              <a:rPr lang="es-ES" sz="1450" b="1" spc="-10">
                 <a:solidFill>
                   <a:srgbClr val="262424"/>
                 </a:solidFill>
                 <a:latin typeface="Tahoma"/>
                 <a:cs typeface="Tahoma"/>
               </a:rPr>
-              <a:t>CONTRAVENTANAS</a:t>
+              <a:t>PROBLEMA 5</a:t>
             </a:r>
             <a:endParaRPr sz="1450">
               <a:latin typeface="Tahoma"/>
               <a:cs typeface="Tahoma"/>
-            </a:endParaRPr>
-          </a:p>
-          <a:p>
-            <a:pPr marL="12700">
-              <a:lnSpc>
-                <a:spcPct val="100000"/>
-              </a:lnSpc>
-              <a:spcBef>
-                <a:spcPts val="585"/>
-              </a:spcBef>
-            </a:pPr>
-            <a:r>
-              <a:rPr sz="1450" dirty="0">
-                <a:solidFill>
-                  <a:srgbClr val="262424"/>
-                </a:solidFill>
-                <a:latin typeface="Microsoft JhengHei UI"/>
-                <a:cs typeface="Microsoft JhengHei UI"/>
-              </a:rPr>
-              <a:t>antiestéticas</a:t>
-            </a:r>
-            <a:r>
-              <a:rPr sz="1450" spc="245" dirty="0">
-                <a:solidFill>
-                  <a:srgbClr val="262424"/>
-                </a:solidFill>
-                <a:latin typeface="Microsoft JhengHei UI"/>
-                <a:cs typeface="Microsoft JhengHei UI"/>
-              </a:rPr>
-              <a:t> </a:t>
-            </a:r>
-            <a:r>
-              <a:rPr sz="1450" dirty="0">
-                <a:solidFill>
-                  <a:srgbClr val="262424"/>
-                </a:solidFill>
-                <a:latin typeface="Microsoft JhengHei UI"/>
-                <a:cs typeface="Microsoft JhengHei UI"/>
-              </a:rPr>
-              <a:t>e</a:t>
-            </a:r>
-            <a:r>
-              <a:rPr sz="1450" spc="245" dirty="0">
-                <a:solidFill>
-                  <a:srgbClr val="262424"/>
-                </a:solidFill>
-                <a:latin typeface="Microsoft JhengHei UI"/>
-                <a:cs typeface="Microsoft JhengHei UI"/>
-              </a:rPr>
-              <a:t> </a:t>
-            </a:r>
-            <a:r>
-              <a:rPr sz="1450" spc="-10" dirty="0">
-                <a:solidFill>
-                  <a:srgbClr val="262424"/>
-                </a:solidFill>
-                <a:latin typeface="Microsoft JhengHei UI"/>
-                <a:cs typeface="Microsoft JhengHei UI"/>
-              </a:rPr>
-              <a:t>inútiles</a:t>
-            </a:r>
-            <a:endParaRPr sz="1450">
-              <a:latin typeface="Microsoft JhengHei UI"/>
-              <a:cs typeface="Microsoft JhengHei UI"/>
             </a:endParaRPr>
           </a:p>
         </p:txBody>
@@ -4901,7 +4837,7 @@
         <p:grpSpPr>
           <a:xfrm>
             <a:off x="4019550" y="1495424"/>
-            <a:ext cx="2952750" cy="2143125"/>
+            <a:ext cx="2952750" cy="3305176"/>
             <a:chOff x="4019550" y="1495424"/>
             <a:chExt cx="2952750" cy="2143125"/>
           </a:xfrm>
@@ -5004,7 +4940,7 @@
           <p:spPr>
             <a:xfrm>
               <a:off x="4220210" y="1708365"/>
-              <a:ext cx="180886" cy="180886"/>
+              <a:ext cx="196926" cy="151453"/>
             </a:xfrm>
             <a:prstGeom prst="rect">
               <a:avLst/>
@@ -5020,7 +4956,7 @@
         </p:nvSpPr>
         <p:spPr>
           <a:xfrm>
-            <a:off x="4596803" y="1646650"/>
+            <a:off x="4596803" y="1751589"/>
             <a:ext cx="2195830" cy="1170940"/>
           </a:xfrm>
           <a:prstGeom prst="rect">
@@ -5252,7 +5188,7 @@
         </p:nvSpPr>
         <p:spPr>
           <a:xfrm>
-            <a:off x="4596803" y="2925495"/>
+            <a:off x="4596803" y="3340572"/>
             <a:ext cx="2054860" cy="520700"/>
           </a:xfrm>
           <a:prstGeom prst="rect">
@@ -5400,7 +5336,7 @@
         </p:nvSpPr>
         <p:spPr>
           <a:xfrm>
-            <a:off x="4007739" y="3752913"/>
+            <a:off x="4019550" y="4998625"/>
             <a:ext cx="2370455" cy="635000"/>
           </a:xfrm>
           <a:prstGeom prst="rect">

</xml_diff>